<commit_message>
docs: finalize printable report and tool registry
</commit_message>
<xml_diff>
--- a/report/llm_security_argus_briefing.pptx
+++ b/report/llm_security_argus_briefing.pptx
@@ -2107,6 +2107,10 @@
             <a:prstDash val="solid"/>
           </a:ln>
         </p:spPr>
+        <p:txBody xmlns:a="http://schemas.openxmlformats.org/drawingml/2006/main">
+          <a:bodyPr/>
+          <a:p/>
+        </p:txBody>
       </p:sp>
       <p:sp>
         <p:nvSpPr>
@@ -2192,6 +2196,10 @@
             <a:prstDash val="solid"/>
           </a:ln>
         </p:spPr>
+        <p:txBody xmlns:a="http://schemas.openxmlformats.org/drawingml/2006/main">
+          <a:bodyPr/>
+          <a:p/>
+        </p:txBody>
       </p:sp>
       <p:sp>
         <p:nvSpPr>
@@ -2605,6 +2613,10 @@
             <a:prstDash val="solid"/>
           </a:ln>
         </p:spPr>
+        <p:txBody xmlns:a="http://schemas.openxmlformats.org/drawingml/2006/main">
+          <a:bodyPr/>
+          <a:p/>
+        </p:txBody>
       </p:sp>
       <p:sp>
         <p:nvSpPr>
@@ -2774,6 +2786,10 @@
             <a:prstDash val="solid"/>
           </a:ln>
         </p:spPr>
+        <p:txBody xmlns:a="http://schemas.openxmlformats.org/drawingml/2006/main">
+          <a:bodyPr/>
+          <a:p/>
+        </p:txBody>
       </p:sp>
       <p:sp>
         <p:nvSpPr>
@@ -2859,6 +2875,10 @@
             <a:prstDash val="solid"/>
           </a:ln>
         </p:spPr>
+        <p:txBody xmlns:a="http://schemas.openxmlformats.org/drawingml/2006/main">
+          <a:bodyPr/>
+          <a:p/>
+        </p:txBody>
       </p:sp>
       <p:sp>
         <p:nvSpPr>
@@ -2944,6 +2964,10 @@
             <a:prstDash val="solid"/>
           </a:ln>
         </p:spPr>
+        <p:txBody xmlns:a="http://schemas.openxmlformats.org/drawingml/2006/main">
+          <a:bodyPr/>
+          <a:p/>
+        </p:txBody>
       </p:sp>
       <p:sp>
         <p:nvSpPr>
@@ -3029,6 +3053,10 @@
             <a:prstDash val="solid"/>
           </a:ln>
         </p:spPr>
+        <p:txBody xmlns:a="http://schemas.openxmlformats.org/drawingml/2006/main">
+          <a:bodyPr/>
+          <a:p/>
+        </p:txBody>
       </p:sp>
       <p:sp>
         <p:nvSpPr>
@@ -3114,6 +3142,10 @@
             <a:prstDash val="solid"/>
           </a:ln>
         </p:spPr>
+        <p:txBody xmlns:a="http://schemas.openxmlformats.org/drawingml/2006/main">
+          <a:bodyPr/>
+          <a:p/>
+        </p:txBody>
       </p:sp>
       <p:sp>
         <p:nvSpPr>
@@ -3199,6 +3231,10 @@
             <a:prstDash val="solid"/>
           </a:ln>
         </p:spPr>
+        <p:txBody xmlns:a="http://schemas.openxmlformats.org/drawingml/2006/main">
+          <a:bodyPr/>
+          <a:p/>
+        </p:txBody>
       </p:sp>
       <p:sp>
         <p:nvSpPr>
@@ -3284,6 +3320,10 @@
             <a:prstDash val="solid"/>
           </a:ln>
         </p:spPr>
+        <p:txBody xmlns:a="http://schemas.openxmlformats.org/drawingml/2006/main">
+          <a:bodyPr/>
+          <a:p/>
+        </p:txBody>
       </p:sp>
       <p:sp>
         <p:nvSpPr>
@@ -3369,6 +3409,10 @@
             <a:prstDash val="solid"/>
           </a:ln>
         </p:spPr>
+        <p:txBody xmlns:a="http://schemas.openxmlformats.org/drawingml/2006/main">
+          <a:bodyPr/>
+          <a:p/>
+        </p:txBody>
       </p:sp>
       <p:sp>
         <p:nvSpPr>
@@ -3681,6 +3725,10 @@
             <a:prstDash val="solid"/>
           </a:ln>
         </p:spPr>
+        <p:txBody xmlns:a="http://schemas.openxmlformats.org/drawingml/2006/main">
+          <a:bodyPr/>
+          <a:p/>
+        </p:txBody>
       </p:sp>
       <p:sp>
         <p:nvSpPr>
@@ -3716,6 +3764,10 @@
             <a:prstDash val="solid"/>
           </a:ln>
         </p:spPr>
+        <p:txBody xmlns:a="http://schemas.openxmlformats.org/drawingml/2006/main">
+          <a:bodyPr/>
+          <a:p/>
+        </p:txBody>
       </p:sp>
       <p:sp>
         <p:nvSpPr>
@@ -3851,6 +3903,10 @@
             <a:prstDash val="solid"/>
           </a:ln>
         </p:spPr>
+        <p:txBody xmlns:a="http://schemas.openxmlformats.org/drawingml/2006/main">
+          <a:bodyPr/>
+          <a:p/>
+        </p:txBody>
       </p:sp>
       <p:sp>
         <p:nvSpPr>
@@ -3986,6 +4042,10 @@
             <a:prstDash val="solid"/>
           </a:ln>
         </p:spPr>
+        <p:txBody xmlns:a="http://schemas.openxmlformats.org/drawingml/2006/main">
+          <a:bodyPr/>
+          <a:p/>
+        </p:txBody>
       </p:sp>
       <p:sp>
         <p:nvSpPr>
@@ -4121,6 +4181,10 @@
             <a:prstDash val="solid"/>
           </a:ln>
         </p:spPr>
+        <p:txBody xmlns:a="http://schemas.openxmlformats.org/drawingml/2006/main">
+          <a:bodyPr/>
+          <a:p/>
+        </p:txBody>
       </p:sp>
       <p:sp>
         <p:nvSpPr>
@@ -4483,6 +4547,10 @@
             <a:prstDash val="solid"/>
           </a:ln>
         </p:spPr>
+        <p:txBody xmlns:a="http://schemas.openxmlformats.org/drawingml/2006/main">
+          <a:bodyPr/>
+          <a:p/>
+        </p:txBody>
       </p:sp>
       <p:sp>
         <p:nvSpPr>
@@ -4518,6 +4586,10 @@
             <a:prstDash val="solid"/>
           </a:ln>
         </p:spPr>
+        <p:txBody xmlns:a="http://schemas.openxmlformats.org/drawingml/2006/main">
+          <a:bodyPr/>
+          <a:p/>
+        </p:txBody>
       </p:sp>
       <p:sp>
         <p:nvSpPr>
@@ -4653,6 +4725,10 @@
             <a:prstDash val="solid"/>
           </a:ln>
         </p:spPr>
+        <p:txBody xmlns:a="http://schemas.openxmlformats.org/drawingml/2006/main">
+          <a:bodyPr/>
+          <a:p/>
+        </p:txBody>
       </p:sp>
       <p:sp>
         <p:nvSpPr>
@@ -4805,6 +4881,10 @@
             <a:prstDash val="solid"/>
           </a:ln>
         </p:spPr>
+        <p:txBody xmlns:a="http://schemas.openxmlformats.org/drawingml/2006/main">
+          <a:bodyPr/>
+          <a:p/>
+        </p:txBody>
       </p:sp>
       <p:sp>
         <p:nvSpPr>
@@ -4957,6 +5037,10 @@
             <a:prstDash val="solid"/>
           </a:ln>
         </p:spPr>
+        <p:txBody xmlns:a="http://schemas.openxmlformats.org/drawingml/2006/main">
+          <a:bodyPr/>
+          <a:p/>
+        </p:txBody>
       </p:sp>
       <p:sp>
         <p:nvSpPr>
@@ -5109,6 +5193,10 @@
             <a:prstDash val="solid"/>
           </a:ln>
         </p:spPr>
+        <p:txBody xmlns:a="http://schemas.openxmlformats.org/drawingml/2006/main">
+          <a:bodyPr/>
+          <a:p/>
+        </p:txBody>
       </p:sp>
       <p:sp>
         <p:nvSpPr>
@@ -5211,6 +5299,10 @@
             <a:prstDash val="solid"/>
           </a:ln>
         </p:spPr>
+        <p:txBody xmlns:a="http://schemas.openxmlformats.org/drawingml/2006/main">
+          <a:bodyPr/>
+          <a:p/>
+        </p:txBody>
       </p:sp>
       <p:sp>
         <p:nvSpPr>
@@ -5346,6 +5438,10 @@
             <a:prstDash val="solid"/>
           </a:ln>
         </p:spPr>
+        <p:txBody xmlns:a="http://schemas.openxmlformats.org/drawingml/2006/main">
+          <a:bodyPr/>
+          <a:p/>
+        </p:txBody>
       </p:sp>
       <p:sp>
         <p:nvSpPr>
@@ -5481,6 +5577,10 @@
             <a:prstDash val="solid"/>
           </a:ln>
         </p:spPr>
+        <p:txBody xmlns:a="http://schemas.openxmlformats.org/drawingml/2006/main">
+          <a:bodyPr/>
+          <a:p/>
+        </p:txBody>
       </p:sp>
       <p:sp>
         <p:nvSpPr>
@@ -5843,6 +5943,10 @@
             <a:prstDash val="solid"/>
           </a:ln>
         </p:spPr>
+        <p:txBody xmlns:a="http://schemas.openxmlformats.org/drawingml/2006/main">
+          <a:bodyPr/>
+          <a:p/>
+        </p:txBody>
       </p:sp>
       <p:sp>
         <p:nvSpPr>
@@ -5878,6 +5982,10 @@
             <a:prstDash val="solid"/>
           </a:ln>
         </p:spPr>
+        <p:txBody xmlns:a="http://schemas.openxmlformats.org/drawingml/2006/main">
+          <a:bodyPr/>
+          <a:p/>
+        </p:txBody>
       </p:sp>
       <p:sp>
         <p:nvSpPr>
@@ -6064,6 +6172,10 @@
             <a:prstDash val="solid"/>
           </a:ln>
         </p:spPr>
+        <p:txBody xmlns:a="http://schemas.openxmlformats.org/drawingml/2006/main">
+          <a:bodyPr/>
+          <a:p/>
+        </p:txBody>
       </p:sp>
       <p:sp>
         <p:nvSpPr>
@@ -6233,6 +6345,10 @@
             <a:prstDash val="solid"/>
           </a:ln>
         </p:spPr>
+        <p:txBody xmlns:a="http://schemas.openxmlformats.org/drawingml/2006/main">
+          <a:bodyPr/>
+          <a:p/>
+        </p:txBody>
       </p:sp>
       <p:sp>
         <p:nvSpPr>
@@ -6385,6 +6501,10 @@
             <a:prstDash val="solid"/>
           </a:ln>
         </p:spPr>
+        <p:txBody xmlns:a="http://schemas.openxmlformats.org/drawingml/2006/main">
+          <a:bodyPr/>
+          <a:p/>
+        </p:txBody>
       </p:sp>
       <p:sp>
         <p:nvSpPr>
@@ -6571,6 +6691,10 @@
             <a:prstDash val="solid"/>
           </a:ln>
         </p:spPr>
+        <p:txBody xmlns:a="http://schemas.openxmlformats.org/drawingml/2006/main">
+          <a:bodyPr/>
+          <a:p/>
+        </p:txBody>
       </p:sp>
       <p:sp>
         <p:nvSpPr>
@@ -6883,6 +7007,10 @@
             <a:prstDash val="solid"/>
           </a:ln>
         </p:spPr>
+        <p:txBody xmlns:a="http://schemas.openxmlformats.org/drawingml/2006/main">
+          <a:bodyPr/>
+          <a:p/>
+        </p:txBody>
       </p:sp>
       <p:sp>
         <p:nvSpPr>
@@ -6918,6 +7046,10 @@
             <a:prstDash val="solid"/>
           </a:ln>
         </p:spPr>
+        <p:txBody xmlns:a="http://schemas.openxmlformats.org/drawingml/2006/main">
+          <a:bodyPr/>
+          <a:p/>
+        </p:txBody>
       </p:sp>
       <p:sp>
         <p:nvSpPr>
@@ -7053,6 +7185,10 @@
             <a:prstDash val="solid"/>
           </a:ln>
         </p:spPr>
+        <p:txBody xmlns:a="http://schemas.openxmlformats.org/drawingml/2006/main">
+          <a:bodyPr/>
+          <a:p/>
+        </p:txBody>
       </p:sp>
       <p:sp>
         <p:nvSpPr>
@@ -7188,6 +7324,10 @@
             <a:prstDash val="solid"/>
           </a:ln>
         </p:spPr>
+        <p:txBody xmlns:a="http://schemas.openxmlformats.org/drawingml/2006/main">
+          <a:bodyPr/>
+          <a:p/>
+        </p:txBody>
       </p:sp>
       <p:sp>
         <p:nvSpPr>
@@ -7273,6 +7413,10 @@
             <a:prstDash val="solid"/>
           </a:ln>
         </p:spPr>
+        <p:txBody xmlns:a="http://schemas.openxmlformats.org/drawingml/2006/main">
+          <a:bodyPr/>
+          <a:p/>
+        </p:txBody>
       </p:sp>
       <p:sp>
         <p:nvSpPr>
@@ -7358,6 +7502,10 @@
             <a:prstDash val="solid"/>
           </a:ln>
         </p:spPr>
+        <p:txBody xmlns:a="http://schemas.openxmlformats.org/drawingml/2006/main">
+          <a:bodyPr/>
+          <a:p/>
+        </p:txBody>
       </p:sp>
       <p:sp>
         <p:nvSpPr>
@@ -7443,6 +7591,10 @@
             <a:prstDash val="solid"/>
           </a:ln>
         </p:spPr>
+        <p:txBody xmlns:a="http://schemas.openxmlformats.org/drawingml/2006/main">
+          <a:bodyPr/>
+          <a:p/>
+        </p:txBody>
       </p:sp>
       <p:sp>
         <p:nvSpPr>
@@ -7528,6 +7680,10 @@
             <a:prstDash val="solid"/>
           </a:ln>
         </p:spPr>
+        <p:txBody xmlns:a="http://schemas.openxmlformats.org/drawingml/2006/main">
+          <a:bodyPr/>
+          <a:p/>
+        </p:txBody>
       </p:sp>
       <p:sp>
         <p:nvSpPr>
@@ -8140,6 +8296,10 @@
             <a:prstDash val="solid"/>
           </a:ln>
         </p:spPr>
+        <p:txBody xmlns:a="http://schemas.openxmlformats.org/drawingml/2006/main">
+          <a:bodyPr/>
+          <a:p/>
+        </p:txBody>
       </p:sp>
       <p:sp>
         <p:nvSpPr>
@@ -8175,6 +8335,10 @@
             <a:prstDash val="solid"/>
           </a:ln>
         </p:spPr>
+        <p:txBody xmlns:a="http://schemas.openxmlformats.org/drawingml/2006/main">
+          <a:bodyPr/>
+          <a:p/>
+        </p:txBody>
       </p:sp>
       <p:sp>
         <p:nvSpPr>
@@ -8310,6 +8474,10 @@
             <a:prstDash val="solid"/>
           </a:ln>
         </p:spPr>
+        <p:txBody xmlns:a="http://schemas.openxmlformats.org/drawingml/2006/main">
+          <a:bodyPr/>
+          <a:p/>
+        </p:txBody>
       </p:sp>
       <p:sp>
         <p:nvSpPr>
@@ -8445,6 +8613,10 @@
             <a:prstDash val="solid"/>
           </a:ln>
         </p:spPr>
+        <p:txBody xmlns:a="http://schemas.openxmlformats.org/drawingml/2006/main">
+          <a:bodyPr/>
+          <a:p/>
+        </p:txBody>
       </p:sp>
       <p:sp>
         <p:nvSpPr>
@@ -8580,6 +8752,10 @@
             <a:prstDash val="solid"/>
           </a:ln>
         </p:spPr>
+        <p:txBody xmlns:a="http://schemas.openxmlformats.org/drawingml/2006/main">
+          <a:bodyPr/>
+          <a:p/>
+        </p:txBody>
       </p:sp>
       <p:sp>
         <p:nvSpPr>
@@ -8715,6 +8891,10 @@
             <a:prstDash val="solid"/>
           </a:ln>
         </p:spPr>
+        <p:txBody xmlns:a="http://schemas.openxmlformats.org/drawingml/2006/main">
+          <a:bodyPr/>
+          <a:p/>
+        </p:txBody>
       </p:sp>
       <p:sp>
         <p:nvSpPr>
@@ -8761,7 +8941,7 @@
                   <a:srgbClr val="7C3AED"/>
                 </a:solidFill>
               </a:rPr>
-              <a:t>1.049ms</a:t>
+              <a:t>0.897ms</a:t>
             </a:r>
           </a:p>
         </p:txBody>
@@ -8916,6 +9096,10 @@
             <a:prstDash val="solid"/>
           </a:ln>
         </p:spPr>
+        <p:txBody xmlns:a="http://schemas.openxmlformats.org/drawingml/2006/main">
+          <a:bodyPr/>
+          <a:p/>
+        </p:txBody>
       </p:sp>
       <p:sp>
         <p:nvSpPr>
@@ -9278,6 +9462,10 @@
             <a:prstDash val="solid"/>
           </a:ln>
         </p:spPr>
+        <p:txBody xmlns:a="http://schemas.openxmlformats.org/drawingml/2006/main">
+          <a:bodyPr/>
+          <a:p/>
+        </p:txBody>
       </p:sp>
       <p:sp>
         <p:nvSpPr>
@@ -9313,6 +9501,10 @@
             <a:prstDash val="solid"/>
           </a:ln>
         </p:spPr>
+        <p:txBody xmlns:a="http://schemas.openxmlformats.org/drawingml/2006/main">
+          <a:bodyPr/>
+          <a:p/>
+        </p:txBody>
       </p:sp>
       <p:sp>
         <p:nvSpPr>
@@ -9448,6 +9640,10 @@
             <a:prstDash val="solid"/>
           </a:ln>
         </p:spPr>
+        <p:txBody xmlns:a="http://schemas.openxmlformats.org/drawingml/2006/main">
+          <a:bodyPr/>
+          <a:p/>
+        </p:txBody>
       </p:sp>
       <p:sp>
         <p:nvSpPr>
@@ -9583,6 +9779,10 @@
             <a:prstDash val="solid"/>
           </a:ln>
         </p:spPr>
+        <p:txBody xmlns:a="http://schemas.openxmlformats.org/drawingml/2006/main">
+          <a:bodyPr/>
+          <a:p/>
+        </p:txBody>
       </p:sp>
       <p:sp>
         <p:nvSpPr>
@@ -9718,6 +9918,10 @@
             <a:prstDash val="solid"/>
           </a:ln>
         </p:spPr>
+        <p:txBody xmlns:a="http://schemas.openxmlformats.org/drawingml/2006/main">
+          <a:bodyPr/>
+          <a:p/>
+        </p:txBody>
       </p:sp>
       <p:sp>
         <p:nvSpPr>
@@ -9853,6 +10057,10 @@
             <a:prstDash val="solid"/>
           </a:ln>
         </p:spPr>
+        <p:txBody xmlns:a="http://schemas.openxmlformats.org/drawingml/2006/main">
+          <a:bodyPr/>
+          <a:p/>
+        </p:txBody>
       </p:sp>
       <p:sp>
         <p:nvSpPr>
@@ -10165,6 +10373,10 @@
             <a:prstDash val="solid"/>
           </a:ln>
         </p:spPr>
+        <p:txBody xmlns:a="http://schemas.openxmlformats.org/drawingml/2006/main">
+          <a:bodyPr/>
+          <a:p/>
+        </p:txBody>
       </p:sp>
       <p:sp>
         <p:nvSpPr>
@@ -10200,6 +10412,10 @@
             <a:prstDash val="solid"/>
           </a:ln>
         </p:spPr>
+        <p:txBody xmlns:a="http://schemas.openxmlformats.org/drawingml/2006/main">
+          <a:bodyPr/>
+          <a:p/>
+        </p:txBody>
       </p:sp>
       <p:sp>
         <p:nvSpPr>
@@ -10335,6 +10551,10 @@
             <a:prstDash val="solid"/>
           </a:ln>
         </p:spPr>
+        <p:txBody xmlns:a="http://schemas.openxmlformats.org/drawingml/2006/main">
+          <a:bodyPr/>
+          <a:p/>
+        </p:txBody>
       </p:sp>
       <p:sp>
         <p:nvSpPr>
@@ -10470,6 +10690,10 @@
             <a:prstDash val="solid"/>
           </a:ln>
         </p:spPr>
+        <p:txBody xmlns:a="http://schemas.openxmlformats.org/drawingml/2006/main">
+          <a:bodyPr/>
+          <a:p/>
+        </p:txBody>
       </p:sp>
       <p:sp>
         <p:nvSpPr>
@@ -10605,6 +10829,10 @@
             <a:prstDash val="solid"/>
           </a:ln>
         </p:spPr>
+        <p:txBody xmlns:a="http://schemas.openxmlformats.org/drawingml/2006/main">
+          <a:bodyPr/>
+          <a:p/>
+        </p:txBody>
       </p:sp>
       <p:sp>
         <p:nvSpPr>

</xml_diff>